<commit_message>
Embed live screenshots into demo deck
</commit_message>
<xml_diff>
--- a/docs/demo-deck.pptx
+++ b/docs/demo-deck.pptx
@@ -4098,12 +4098,20 @@
           </a:p>
         </p:txBody>
       </p:sp>
-      <p:sp>
-        <p:nvSpPr>
-          <p:cNvPr id="7" name="Rectangle 6"/>
-          <p:cNvSpPr/>
+      <p:pic>
+        <p:nvPicPr>
+          <p:cNvPr id="7" name="Picture 6" descr="02-dashboard.png"/>
+          <p:cNvPicPr>
+            <a:picLocks noChangeAspect="1"/>
+          </p:cNvPicPr>
           <p:nvPr/>
-        </p:nvSpPr>
+        </p:nvPicPr>
+        <p:blipFill>
+          <a:blip r:embed="rId2"/>
+          <a:stretch>
+            <a:fillRect/>
+          </a:stretch>
+        </p:blipFill>
         <p:spPr>
           <a:xfrm>
             <a:off x="5486400" y="2011680"/>
@@ -4112,47 +4120,8 @@
           <a:prstGeom prst="rect">
             <a:avLst/>
           </a:prstGeom>
-          <a:solidFill>
-            <a:srgbClr val="F4F4F5"/>
-          </a:solidFill>
-          <a:ln w="12700">
-            <a:solidFill>
-              <a:srgbClr val="E4E4E7"/>
-            </a:solidFill>
-          </a:ln>
-        </p:spPr>
-        <p:style>
-          <a:lnRef idx="1">
-            <a:schemeClr val="accent1"/>
-          </a:lnRef>
-          <a:fillRef idx="3">
-            <a:schemeClr val="accent1"/>
-          </a:fillRef>
-          <a:effectRef idx="2">
-            <a:schemeClr val="accent1"/>
-          </a:effectRef>
-          <a:fontRef idx="minor">
-            <a:schemeClr val="lt1"/>
-          </a:fontRef>
-        </p:style>
-        <p:txBody>
-          <a:bodyPr rtlCol="0" anchor="ctr" lIns="182880" rIns="182880" tIns="182880" bIns="182880" wrap="square"/>
-          <a:lstStyle/>
-          <a:p>
-            <a:pPr algn="ctr"/>
-            <a:r>
-              <a:rPr sz="1400" i="1">
-                <a:solidFill>
-                  <a:srgbClr val="A1A1AA"/>
-                </a:solidFill>
-                <a:latin typeface="Inter"/>
-              </a:rPr>
-              <a:t>[ screenshot: 02-dashboard.png ]
-Dashboard — stats + qualified visitor table</a:t>
-            </a:r>
-          </a:p>
-        </p:txBody>
-      </p:sp>
+        </p:spPr>
+      </p:pic>
       <p:sp>
         <p:nvSpPr>
           <p:cNvPr id="8" name="TextBox 7"/>
@@ -4481,12 +4450,20 @@
           </a:p>
         </p:txBody>
       </p:sp>
-      <p:sp>
-        <p:nvSpPr>
-          <p:cNvPr id="7" name="Rectangle 6"/>
-          <p:cNvSpPr/>
+      <p:pic>
+        <p:nvPicPr>
+          <p:cNvPr id="7" name="Picture 6" descr="03-score.png"/>
+          <p:cNvPicPr>
+            <a:picLocks noChangeAspect="1"/>
+          </p:cNvPicPr>
           <p:nvPr/>
-        </p:nvSpPr>
+        </p:nvPicPr>
+        <p:blipFill>
+          <a:blip r:embed="rId2"/>
+          <a:stretch>
+            <a:fillRect/>
+          </a:stretch>
+        </p:blipFill>
         <p:spPr>
           <a:xfrm>
             <a:off x="5486400" y="2011680"/>
@@ -4495,47 +4472,8 @@
           <a:prstGeom prst="rect">
             <a:avLst/>
           </a:prstGeom>
-          <a:solidFill>
-            <a:srgbClr val="F4F4F5"/>
-          </a:solidFill>
-          <a:ln w="12700">
-            <a:solidFill>
-              <a:srgbClr val="E4E4E7"/>
-            </a:solidFill>
-          </a:ln>
-        </p:spPr>
-        <p:style>
-          <a:lnRef idx="1">
-            <a:schemeClr val="accent1"/>
-          </a:lnRef>
-          <a:fillRef idx="3">
-            <a:schemeClr val="accent1"/>
-          </a:fillRef>
-          <a:effectRef idx="2">
-            <a:schemeClr val="accent1"/>
-          </a:effectRef>
-          <a:fontRef idx="minor">
-            <a:schemeClr val="lt1"/>
-          </a:fontRef>
-        </p:style>
-        <p:txBody>
-          <a:bodyPr rtlCol="0" anchor="ctr" lIns="182880" rIns="182880" tIns="182880" bIns="182880" wrap="square"/>
-          <a:lstStyle/>
-          <a:p>
-            <a:pPr algn="ctr"/>
-            <a:r>
-              <a:rPr sz="1400" i="1">
-                <a:solidFill>
-                  <a:srgbClr val="A1A1AA"/>
-                </a:solidFill>
-                <a:latin typeface="Inter"/>
-              </a:rPr>
-              <a:t>[ screenshot: 03-score.png ]
-Visitor detail — Score Reasoning popover</a:t>
-            </a:r>
-          </a:p>
-        </p:txBody>
-      </p:sp>
+        </p:spPr>
+      </p:pic>
       <p:sp>
         <p:nvSpPr>
           <p:cNvPr id="8" name="TextBox 7"/>
@@ -4848,12 +4786,20 @@
           </a:p>
         </p:txBody>
       </p:sp>
-      <p:sp>
-        <p:nvSpPr>
-          <p:cNvPr id="7" name="Rectangle 6"/>
-          <p:cNvSpPr/>
+      <p:pic>
+        <p:nvPicPr>
+          <p:cNvPr id="7" name="Picture 6" descr="03-score.png"/>
+          <p:cNvPicPr>
+            <a:picLocks noChangeAspect="1"/>
+          </p:cNvPicPr>
           <p:nvPr/>
-        </p:nvSpPr>
+        </p:nvPicPr>
+        <p:blipFill>
+          <a:blip r:embed="rId2"/>
+          <a:stretch>
+            <a:fillRect/>
+          </a:stretch>
+        </p:blipFill>
         <p:spPr>
           <a:xfrm>
             <a:off x="5486400" y="2011680"/>
@@ -4862,47 +4808,8 @@
           <a:prstGeom prst="rect">
             <a:avLst/>
           </a:prstGeom>
-          <a:solidFill>
-            <a:srgbClr val="F4F4F5"/>
-          </a:solidFill>
-          <a:ln w="12700">
-            <a:solidFill>
-              <a:srgbClr val="E4E4E7"/>
-            </a:solidFill>
-          </a:ln>
-        </p:spPr>
-        <p:style>
-          <a:lnRef idx="1">
-            <a:schemeClr val="accent1"/>
-          </a:lnRef>
-          <a:fillRef idx="3">
-            <a:schemeClr val="accent1"/>
-          </a:fillRef>
-          <a:effectRef idx="2">
-            <a:schemeClr val="accent1"/>
-          </a:effectRef>
-          <a:fontRef idx="minor">
-            <a:schemeClr val="lt1"/>
-          </a:fontRef>
-        </p:style>
-        <p:txBody>
-          <a:bodyPr rtlCol="0" anchor="ctr" lIns="182880" rIns="182880" tIns="182880" bIns="182880" wrap="square"/>
-          <a:lstStyle/>
-          <a:p>
-            <a:pPr algn="ctr"/>
-            <a:r>
-              <a:rPr sz="1400" i="1">
-                <a:solidFill>
-                  <a:srgbClr val="A1A1AA"/>
-                </a:solidFill>
-                <a:latin typeface="Inter"/>
-              </a:rPr>
-              <a:t>[ screenshot: 04-crm.png ]
-Visitor detail — CRM &amp; Prior Touchpoints card</a:t>
-            </a:r>
-          </a:p>
-        </p:txBody>
-      </p:sp>
+        </p:spPr>
+      </p:pic>
       <p:sp>
         <p:nvSpPr>
           <p:cNvPr id="8" name="TextBox 7"/>
@@ -5231,12 +5138,20 @@
           </a:p>
         </p:txBody>
       </p:sp>
-      <p:sp>
-        <p:nvSpPr>
-          <p:cNvPr id="7" name="Rectangle 6"/>
-          <p:cNvSpPr/>
+      <p:pic>
+        <p:nvPicPr>
+          <p:cNvPr id="7" name="Picture 6" descr="05-outreach.png"/>
+          <p:cNvPicPr>
+            <a:picLocks noChangeAspect="1"/>
+          </p:cNvPicPr>
           <p:nvPr/>
-        </p:nvSpPr>
+        </p:nvPicPr>
+        <p:blipFill>
+          <a:blip r:embed="rId2"/>
+          <a:stretch>
+            <a:fillRect/>
+          </a:stretch>
+        </p:blipFill>
         <p:spPr>
           <a:xfrm>
             <a:off x="5486400" y="2011680"/>
@@ -5245,47 +5160,8 @@
           <a:prstGeom prst="rect">
             <a:avLst/>
           </a:prstGeom>
-          <a:solidFill>
-            <a:srgbClr val="F4F4F5"/>
-          </a:solidFill>
-          <a:ln w="12700">
-            <a:solidFill>
-              <a:srgbClr val="E4E4E7"/>
-            </a:solidFill>
-          </a:ln>
-        </p:spPr>
-        <p:style>
-          <a:lnRef idx="1">
-            <a:schemeClr val="accent1"/>
-          </a:lnRef>
-          <a:fillRef idx="3">
-            <a:schemeClr val="accent1"/>
-          </a:fillRef>
-          <a:effectRef idx="2">
-            <a:schemeClr val="accent1"/>
-          </a:effectRef>
-          <a:fontRef idx="minor">
-            <a:schemeClr val="lt1"/>
-          </a:fontRef>
-        </p:style>
-        <p:txBody>
-          <a:bodyPr rtlCol="0" anchor="ctr" lIns="182880" rIns="182880" tIns="182880" bIns="182880" wrap="square"/>
-          <a:lstStyle/>
-          <a:p>
-            <a:pPr algn="ctr"/>
-            <a:r>
-              <a:rPr sz="1400" i="1">
-                <a:solidFill>
-                  <a:srgbClr val="A1A1AA"/>
-                </a:solidFill>
-                <a:latin typeface="Inter"/>
-              </a:rPr>
-              <a:t>[ screenshot: 05-outreach.png ]
-Generated outreach email + Copy / Send controls</a:t>
-            </a:r>
-          </a:p>
-        </p:txBody>
-      </p:sp>
+        </p:spPr>
+      </p:pic>
       <p:sp>
         <p:nvSpPr>
           <p:cNvPr id="8" name="TextBox 7"/>

</xml_diff>